<commit_message>
batch vectorisation is coded and accelerates the compute time !
</commit_message>
<xml_diff>
--- a/docs/Diagrams_and_formulaes.pptx
+++ b/docs/Diagrams_and_formulaes.pptx
@@ -270,7 +270,7 @@
           <a:p>
             <a:fld id="{8CC8168F-B74C-4525-A6F8-EBA84798C097}" type="datetimeFigureOut">
               <a:rPr lang="fr-FR" smtClean="0"/>
-              <a:t>08/08/2025</a:t>
+              <a:t>09/08/2025</a:t>
             </a:fld>
             <a:endParaRPr lang="fr-FR"/>
           </a:p>
@@ -468,7 +468,7 @@
           <a:p>
             <a:fld id="{8CC8168F-B74C-4525-A6F8-EBA84798C097}" type="datetimeFigureOut">
               <a:rPr lang="fr-FR" smtClean="0"/>
-              <a:t>08/08/2025</a:t>
+              <a:t>09/08/2025</a:t>
             </a:fld>
             <a:endParaRPr lang="fr-FR"/>
           </a:p>
@@ -676,7 +676,7 @@
           <a:p>
             <a:fld id="{8CC8168F-B74C-4525-A6F8-EBA84798C097}" type="datetimeFigureOut">
               <a:rPr lang="fr-FR" smtClean="0"/>
-              <a:t>08/08/2025</a:t>
+              <a:t>09/08/2025</a:t>
             </a:fld>
             <a:endParaRPr lang="fr-FR"/>
           </a:p>
@@ -874,7 +874,7 @@
           <a:p>
             <a:fld id="{8CC8168F-B74C-4525-A6F8-EBA84798C097}" type="datetimeFigureOut">
               <a:rPr lang="fr-FR" smtClean="0"/>
-              <a:t>08/08/2025</a:t>
+              <a:t>09/08/2025</a:t>
             </a:fld>
             <a:endParaRPr lang="fr-FR"/>
           </a:p>
@@ -1149,7 +1149,7 @@
           <a:p>
             <a:fld id="{8CC8168F-B74C-4525-A6F8-EBA84798C097}" type="datetimeFigureOut">
               <a:rPr lang="fr-FR" smtClean="0"/>
-              <a:t>08/08/2025</a:t>
+              <a:t>09/08/2025</a:t>
             </a:fld>
             <a:endParaRPr lang="fr-FR"/>
           </a:p>
@@ -1414,7 +1414,7 @@
           <a:p>
             <a:fld id="{8CC8168F-B74C-4525-A6F8-EBA84798C097}" type="datetimeFigureOut">
               <a:rPr lang="fr-FR" smtClean="0"/>
-              <a:t>08/08/2025</a:t>
+              <a:t>09/08/2025</a:t>
             </a:fld>
             <a:endParaRPr lang="fr-FR"/>
           </a:p>
@@ -1826,7 +1826,7 @@
           <a:p>
             <a:fld id="{8CC8168F-B74C-4525-A6F8-EBA84798C097}" type="datetimeFigureOut">
               <a:rPr lang="fr-FR" smtClean="0"/>
-              <a:t>08/08/2025</a:t>
+              <a:t>09/08/2025</a:t>
             </a:fld>
             <a:endParaRPr lang="fr-FR"/>
           </a:p>
@@ -1967,7 +1967,7 @@
           <a:p>
             <a:fld id="{8CC8168F-B74C-4525-A6F8-EBA84798C097}" type="datetimeFigureOut">
               <a:rPr lang="fr-FR" smtClean="0"/>
-              <a:t>08/08/2025</a:t>
+              <a:t>09/08/2025</a:t>
             </a:fld>
             <a:endParaRPr lang="fr-FR"/>
           </a:p>
@@ -2080,7 +2080,7 @@
           <a:p>
             <a:fld id="{8CC8168F-B74C-4525-A6F8-EBA84798C097}" type="datetimeFigureOut">
               <a:rPr lang="fr-FR" smtClean="0"/>
-              <a:t>08/08/2025</a:t>
+              <a:t>09/08/2025</a:t>
             </a:fld>
             <a:endParaRPr lang="fr-FR"/>
           </a:p>
@@ -2391,7 +2391,7 @@
           <a:p>
             <a:fld id="{8CC8168F-B74C-4525-A6F8-EBA84798C097}" type="datetimeFigureOut">
               <a:rPr lang="fr-FR" smtClean="0"/>
-              <a:t>08/08/2025</a:t>
+              <a:t>09/08/2025</a:t>
             </a:fld>
             <a:endParaRPr lang="fr-FR"/>
           </a:p>
@@ -2679,7 +2679,7 @@
           <a:p>
             <a:fld id="{8CC8168F-B74C-4525-A6F8-EBA84798C097}" type="datetimeFigureOut">
               <a:rPr lang="fr-FR" smtClean="0"/>
-              <a:t>08/08/2025</a:t>
+              <a:t>09/08/2025</a:t>
             </a:fld>
             <a:endParaRPr lang="fr-FR"/>
           </a:p>
@@ -2920,7 +2920,7 @@
           <a:p>
             <a:fld id="{8CC8168F-B74C-4525-A6F8-EBA84798C097}" type="datetimeFigureOut">
               <a:rPr lang="fr-FR" smtClean="0"/>
-              <a:t>08/08/2025</a:t>
+              <a:t>09/08/2025</a:t>
             </a:fld>
             <a:endParaRPr lang="fr-FR"/>
           </a:p>
@@ -18440,7 +18440,7 @@
             <p:spPr>
               <a:xfrm>
                 <a:off x="4124936" y="2767008"/>
-                <a:ext cx="3536609" cy="2325701"/>
+                <a:ext cx="3329886" cy="2708627"/>
               </a:xfrm>
               <a:prstGeom prst="rect">
                 <a:avLst/>
@@ -18872,18 +18872,6 @@
                               </a:rPr>
                               <m:t>𝑖𝑚𝑎𝑔𝑒</m:t>
                             </m:r>
-                            <m:r>
-                              <a:rPr lang="fr-FR" b="0" i="1" smtClean="0">
-                                <a:latin typeface="Cambria Math" panose="02040503050406030204" pitchFamily="18" charset="0"/>
-                              </a:rPr>
-                              <m:t>_</m:t>
-                            </m:r>
-                            <m:r>
-                              <a:rPr lang="fr-FR" b="0" i="1" smtClean="0">
-                                <a:latin typeface="Cambria Math" panose="02040503050406030204" pitchFamily="18" charset="0"/>
-                              </a:rPr>
-                              <m:t>𝑙</m:t>
-                            </m:r>
                           </m:sub>
                         </m:sSub>
                       </m:num>
@@ -18942,51 +18930,26 @@
                         </m:ctrlPr>
                       </m:dPr>
                       <m:e>
-                        <m:sSub>
-                          <m:sSubPr>
-                            <m:ctrlPr>
-                              <a:rPr lang="fr-FR" i="1" smtClean="0">
-                                <a:latin typeface="Cambria Math" panose="02040503050406030204" pitchFamily="18" charset="0"/>
-                              </a:rPr>
-                            </m:ctrlPr>
-                          </m:sSubPr>
-                          <m:e>
-                            <m:r>
-                              <a:rPr lang="fr-FR" b="0" i="1" smtClean="0">
-                                <a:latin typeface="Cambria Math" panose="02040503050406030204" pitchFamily="18" charset="0"/>
-                              </a:rPr>
-                              <m:t>𝑦</m:t>
-                            </m:r>
-                          </m:e>
-                          <m:sub>
-                            <m:r>
-                              <a:rPr lang="fr-FR" b="0" i="1" smtClean="0">
-                                <a:latin typeface="Cambria Math" panose="02040503050406030204" pitchFamily="18" charset="0"/>
-                              </a:rPr>
-                              <m:t>/</m:t>
-                            </m:r>
-                            <m:r>
-                              <a:rPr lang="fr-FR" b="0" i="1" smtClean="0">
-                                <a:latin typeface="Cambria Math" panose="02040503050406030204" pitchFamily="18" charset="0"/>
-                              </a:rPr>
-                              <m:t>𝑙</m:t>
-                            </m:r>
-                          </m:sub>
-                        </m:sSub>
+                        <m:r>
+                          <a:rPr lang="fr-FR" i="1" smtClean="0">
+                            <a:latin typeface="Cambria Math" panose="02040503050406030204" pitchFamily="18" charset="0"/>
+                          </a:rPr>
+                          <m:t>𝑦</m:t>
+                        </m:r>
                         <m:r>
                           <a:rPr lang="fr-FR" i="1">
                             <a:latin typeface="Cambria Math" panose="02040503050406030204" pitchFamily="18" charset="0"/>
                           </a:rPr>
                           <m:t>−</m:t>
                         </m:r>
-                        <m:sSubSup>
-                          <m:sSubSupPr>
+                        <m:sSup>
+                          <m:sSupPr>
                             <m:ctrlPr>
                               <a:rPr lang="fr-FR" i="1" smtClean="0">
                                 <a:latin typeface="Cambria Math" panose="02040503050406030204" pitchFamily="18" charset="0"/>
                               </a:rPr>
                             </m:ctrlPr>
-                          </m:sSubSupPr>
+                          </m:sSupPr>
                           <m:e>
                             <m:r>
                               <a:rPr lang="fr-FR" b="0" i="1" smtClean="0">
@@ -18995,20 +18958,6 @@
                               <m:t>𝐴</m:t>
                             </m:r>
                           </m:e>
-                          <m:sub>
-                            <m:r>
-                              <a:rPr lang="fr-FR" b="0" i="1" smtClean="0">
-                                <a:latin typeface="Cambria Math" panose="02040503050406030204" pitchFamily="18" charset="0"/>
-                              </a:rPr>
-                              <m:t>/</m:t>
-                            </m:r>
-                            <m:r>
-                              <a:rPr lang="fr-FR" b="0" i="1" smtClean="0">
-                                <a:latin typeface="Cambria Math" panose="02040503050406030204" pitchFamily="18" charset="0"/>
-                              </a:rPr>
-                              <m:t>𝑙</m:t>
-                            </m:r>
-                          </m:sub>
                           <m:sup>
                             <m:r>
                               <a:rPr lang="fr-FR" b="0" i="1" smtClean="0">
@@ -19023,7 +18972,7 @@
                               <m:t>−1</m:t>
                             </m:r>
                           </m:sup>
-                        </m:sSubSup>
+                        </m:sSup>
                       </m:e>
                     </m:d>
                     <m:r>
@@ -19052,6 +19001,193 @@
                 </a:r>
               </a:p>
               <a:p>
+                <a:pPr/>
+                <a14:m>
+                  <m:oMathPara xmlns:m="http://schemas.openxmlformats.org/officeDocument/2006/math">
+                    <m:oMathParaPr>
+                      <m:jc m:val="centerGroup"/>
+                    </m:oMathParaPr>
+                    <m:oMath xmlns:m="http://schemas.openxmlformats.org/officeDocument/2006/math">
+                      <m:borderBox>
+                        <m:borderBoxPr>
+                          <m:ctrlPr>
+                            <a:rPr lang="fr-FR" i="1" smtClean="0">
+                              <a:latin typeface="Cambria Math" panose="02040503050406030204" pitchFamily="18" charset="0"/>
+                            </a:rPr>
+                          </m:ctrlPr>
+                        </m:borderBoxPr>
+                        <m:e>
+                          <m:f>
+                            <m:fPr>
+                              <m:ctrlPr>
+                                <a:rPr lang="fr-FR" i="1">
+                                  <a:latin typeface="Cambria Math" panose="02040503050406030204" pitchFamily="18" charset="0"/>
+                                </a:rPr>
+                              </m:ctrlPr>
+                            </m:fPr>
+                            <m:num>
+                              <m:r>
+                                <a:rPr lang="fr-FR" i="1">
+                                  <a:latin typeface="Cambria Math" panose="02040503050406030204" pitchFamily="18" charset="0"/>
+                                </a:rPr>
+                                <m:t>𝜕</m:t>
+                              </m:r>
+                              <m:sSub>
+                                <m:sSubPr>
+                                  <m:ctrlPr>
+                                    <a:rPr lang="fr-FR" i="1">
+                                      <a:latin typeface="Cambria Math" panose="02040503050406030204" pitchFamily="18" charset="0"/>
+                                    </a:rPr>
+                                  </m:ctrlPr>
+                                </m:sSubPr>
+                                <m:e>
+                                  <m:r>
+                                    <a:rPr lang="fr-FR" i="1">
+                                      <a:latin typeface="Cambria Math" panose="02040503050406030204" pitchFamily="18" charset="0"/>
+                                    </a:rPr>
+                                    <m:t>𝐶</m:t>
+                                  </m:r>
+                                </m:e>
+                                <m:sub>
+                                  <m:r>
+                                    <a:rPr lang="fr-FR" i="1">
+                                      <a:latin typeface="Cambria Math" panose="02040503050406030204" pitchFamily="18" charset="0"/>
+                                    </a:rPr>
+                                    <m:t>/</m:t>
+                                  </m:r>
+                                  <m:r>
+                                    <a:rPr lang="fr-FR" i="1">
+                                      <a:latin typeface="Cambria Math" panose="02040503050406030204" pitchFamily="18" charset="0"/>
+                                    </a:rPr>
+                                    <m:t>𝑖𝑚𝑎𝑔𝑒</m:t>
+                                  </m:r>
+                                </m:sub>
+                              </m:sSub>
+                            </m:num>
+                            <m:den>
+                              <m:r>
+                                <a:rPr lang="fr-FR" i="1">
+                                  <a:latin typeface="Cambria Math" panose="02040503050406030204" pitchFamily="18" charset="0"/>
+                                </a:rPr>
+                                <m:t>𝜕</m:t>
+                              </m:r>
+                              <m:sSup>
+                                <m:sSupPr>
+                                  <m:ctrlPr>
+                                    <a:rPr lang="fr-FR" b="1" i="1">
+                                      <a:latin typeface="Cambria Math" panose="02040503050406030204" pitchFamily="18" charset="0"/>
+                                    </a:rPr>
+                                  </m:ctrlPr>
+                                </m:sSupPr>
+                                <m:e>
+                                  <m:r>
+                                    <a:rPr lang="fr-FR" b="1" i="0">
+                                      <a:latin typeface="Cambria Math" panose="02040503050406030204" pitchFamily="18" charset="0"/>
+                                    </a:rPr>
+                                    <m:t>𝐀</m:t>
+                                  </m:r>
+                                </m:e>
+                                <m:sup>
+                                  <m:r>
+                                    <a:rPr lang="fr-FR" b="1" i="0">
+                                      <a:latin typeface="Cambria Math" panose="02040503050406030204" pitchFamily="18" charset="0"/>
+                                    </a:rPr>
+                                    <m:t>𝐍</m:t>
+                                  </m:r>
+                                  <m:r>
+                                    <a:rPr lang="fr-FR" b="1" i="0">
+                                      <a:latin typeface="Cambria Math" panose="02040503050406030204" pitchFamily="18" charset="0"/>
+                                    </a:rPr>
+                                    <m:t>−</m:t>
+                                  </m:r>
+                                  <m:r>
+                                    <a:rPr lang="fr-FR" b="1" i="0">
+                                      <a:latin typeface="Cambria Math" panose="02040503050406030204" pitchFamily="18" charset="0"/>
+                                    </a:rPr>
+                                    <m:t>𝟏</m:t>
+                                  </m:r>
+                                </m:sup>
+                              </m:sSup>
+                            </m:den>
+                          </m:f>
+                          <m:r>
+                            <a:rPr lang="fr-FR" i="1">
+                              <a:latin typeface="Cambria Math" panose="02040503050406030204" pitchFamily="18" charset="0"/>
+                            </a:rPr>
+                            <m:t>=−2 ∗</m:t>
+                          </m:r>
+                          <m:d>
+                            <m:dPr>
+                              <m:ctrlPr>
+                                <a:rPr lang="fr-FR" i="1">
+                                  <a:latin typeface="Cambria Math" panose="02040503050406030204" pitchFamily="18" charset="0"/>
+                                </a:rPr>
+                              </m:ctrlPr>
+                            </m:dPr>
+                            <m:e>
+                              <m:r>
+                                <a:rPr lang="fr-FR" b="1" i="0">
+                                  <a:latin typeface="Cambria Math" panose="02040503050406030204" pitchFamily="18" charset="0"/>
+                                </a:rPr>
+                                <m:t>𝐲</m:t>
+                              </m:r>
+                              <m:r>
+                                <a:rPr lang="fr-FR" i="1">
+                                  <a:latin typeface="Cambria Math" panose="02040503050406030204" pitchFamily="18" charset="0"/>
+                                </a:rPr>
+                                <m:t>−</m:t>
+                              </m:r>
+                              <m:sSup>
+                                <m:sSupPr>
+                                  <m:ctrlPr>
+                                    <a:rPr lang="fr-FR" b="1" i="1">
+                                      <a:latin typeface="Cambria Math" panose="02040503050406030204" pitchFamily="18" charset="0"/>
+                                    </a:rPr>
+                                  </m:ctrlPr>
+                                </m:sSupPr>
+                                <m:e>
+                                  <m:r>
+                                    <a:rPr lang="fr-FR" b="1" i="0">
+                                      <a:latin typeface="Cambria Math" panose="02040503050406030204" pitchFamily="18" charset="0"/>
+                                    </a:rPr>
+                                    <m:t>𝐀</m:t>
+                                  </m:r>
+                                </m:e>
+                                <m:sup>
+                                  <m:r>
+                                    <a:rPr lang="fr-FR" b="1" i="0">
+                                      <a:latin typeface="Cambria Math" panose="02040503050406030204" pitchFamily="18" charset="0"/>
+                                    </a:rPr>
+                                    <m:t>𝐍</m:t>
+                                  </m:r>
+                                  <m:r>
+                                    <a:rPr lang="fr-FR" b="1" i="0">
+                                      <a:latin typeface="Cambria Math" panose="02040503050406030204" pitchFamily="18" charset="0"/>
+                                    </a:rPr>
+                                    <m:t>−</m:t>
+                                  </m:r>
+                                  <m:r>
+                                    <a:rPr lang="fr-FR" b="1" i="0">
+                                      <a:latin typeface="Cambria Math" panose="02040503050406030204" pitchFamily="18" charset="0"/>
+                                    </a:rPr>
+                                    <m:t>𝟏</m:t>
+                                  </m:r>
+                                </m:sup>
+                              </m:sSup>
+                            </m:e>
+                          </m:d>
+                          <m:r>
+                            <m:rPr>
+                              <m:nor/>
+                            </m:rPr>
+                            <a:rPr lang="fr-FR" dirty="0"/>
+                            <m:t>  </m:t>
+                          </m:r>
+                        </m:e>
+                      </m:borderBox>
+                    </m:oMath>
+                  </m:oMathPara>
+                </a14:m>
                 <a:endParaRPr lang="fr-FR" dirty="0"/>
               </a:p>
               <a:p>
@@ -19078,7 +19214,7 @@
             <p:spPr>
               <a:xfrm>
                 <a:off x="4124936" y="2767008"/>
-                <a:ext cx="3536609" cy="2325701"/>
+                <a:ext cx="3329886" cy="2708627"/>
               </a:xfrm>
               <a:prstGeom prst="rect">
                 <a:avLst/>
@@ -19086,7 +19222,7 @@
               <a:blipFill>
                 <a:blip r:embed="rId2"/>
                 <a:stretch>
-                  <a:fillRect l="-172"/>
+                  <a:fillRect l="-183"/>
                 </a:stretch>
               </a:blipFill>
             </p:spPr>
@@ -20281,8 +20417,8 @@
           </p:sp>
         </mc:Fallback>
       </mc:AlternateContent>
-      <mc:AlternateContent xmlns:mc="http://schemas.openxmlformats.org/markup-compatibility/2006" xmlns:a14="http://schemas.microsoft.com/office/drawing/2010/main">
-        <mc:Choice Requires="a14">
+      <mc:AlternateContent xmlns:mc="http://schemas.openxmlformats.org/markup-compatibility/2006">
+        <mc:Choice xmlns:a14="http://schemas.microsoft.com/office/drawing/2010/main" Requires="a14">
           <p:sp>
             <p:nvSpPr>
               <p:cNvPr id="95" name="ZoneTexte 94">
@@ -24262,7 +24398,7 @@
             </p:txBody>
           </p:sp>
         </mc:Choice>
-        <mc:Fallback xmlns="">
+        <mc:Fallback>
           <p:sp>
             <p:nvSpPr>
               <p:cNvPr id="95" name="ZoneTexte 94">
@@ -24342,6 +24478,45 @@
           </a:p>
         </p:txBody>
       </p:sp>
+      <p:sp>
+        <p:nvSpPr>
+          <p:cNvPr id="2" name="ZoneTexte 1">
+            <a:extLst>
+              <a:ext uri="{FF2B5EF4-FFF2-40B4-BE49-F238E27FC236}">
+                <a16:creationId xmlns:a16="http://schemas.microsoft.com/office/drawing/2014/main" id="{455C33EB-70EF-AAC0-5ADF-86D8119D6C04}"/>
+              </a:ext>
+            </a:extLst>
+          </p:cNvPr>
+          <p:cNvSpPr txBox="1"/>
+          <p:nvPr/>
+        </p:nvSpPr>
+        <p:spPr>
+          <a:xfrm>
+            <a:off x="646981" y="4451230"/>
+            <a:ext cx="3528204" cy="646331"/>
+          </a:xfrm>
+          <a:prstGeom prst="rect">
+            <a:avLst/>
+          </a:prstGeom>
+          <a:noFill/>
+        </p:spPr>
+        <p:txBody>
+          <a:bodyPr wrap="square" rtlCol="0">
+            <a:spAutoFit/>
+          </a:bodyPr>
+          <a:lstStyle/>
+          <a:p>
+            <a:r>
+              <a:rPr lang="fr-FR" dirty="0" err="1"/>
+              <a:t>rq</a:t>
+            </a:r>
+            <a:r>
+              <a:rPr lang="fr-FR" dirty="0"/>
+              <a:t> : toutes les variables sont à b (batch) fixé.</a:t>
+            </a:r>
+          </a:p>
+        </p:txBody>
+      </p:sp>
     </p:spTree>
     <p:extLst>
       <p:ext uri="{BB962C8B-B14F-4D97-AF65-F5344CB8AC3E}">
@@ -24374,10 +24549,10 @@
       </p:grpSpPr>
       <p:pic>
         <p:nvPicPr>
-          <p:cNvPr id="3" name="Image 2" descr="Une image contenant dessin, croquis, Dessin d’enfant, conception">
+          <p:cNvPr id="4" name="Image 3">
             <a:extLst>
               <a:ext uri="{FF2B5EF4-FFF2-40B4-BE49-F238E27FC236}">
-                <a16:creationId xmlns:a16="http://schemas.microsoft.com/office/drawing/2014/main" id="{2FADA9EE-6C43-2762-C609-CF5DC462D0AC}"/>
+                <a16:creationId xmlns:a16="http://schemas.microsoft.com/office/drawing/2014/main" id="{E2AF7E4D-21CC-CCB4-4869-A222310E5C55}"/>
               </a:ext>
             </a:extLst>
           </p:cNvPr>
@@ -24387,22 +24562,15 @@
           <p:nvPr/>
         </p:nvPicPr>
         <p:blipFill>
-          <a:blip r:embed="rId2">
-            <a:extLst>
-              <a:ext uri="{28A0092B-C50C-407E-A947-70E740481C1C}">
-                <a14:useLocalDpi xmlns:a14="http://schemas.microsoft.com/office/drawing/2010/main" val="0"/>
-              </a:ext>
-            </a:extLst>
-          </a:blip>
-          <a:srcRect l="6763" t="6825" r="26937" b="19735"/>
+          <a:blip r:embed="rId2"/>
           <a:stretch>
             <a:fillRect/>
           </a:stretch>
         </p:blipFill>
         <p:spPr>
           <a:xfrm>
-            <a:off x="6270498" y="2450840"/>
-            <a:ext cx="5400136" cy="3812875"/>
+            <a:off x="5189300" y="1923102"/>
+            <a:ext cx="7002700" cy="4832849"/>
           </a:xfrm>
           <a:prstGeom prst="rect">
             <a:avLst/>
@@ -27434,229 +27602,8 @@
           </p:sp>
         </mc:Fallback>
       </mc:AlternateContent>
-      <mc:AlternateContent xmlns:mc="http://schemas.openxmlformats.org/markup-compatibility/2006" xmlns:a14="http://schemas.microsoft.com/office/drawing/2010/main">
-        <mc:Choice Requires="a14">
-          <p:sp>
-            <p:nvSpPr>
-              <p:cNvPr id="38" name="ZoneTexte 37">
-                <a:extLst>
-                  <a:ext uri="{FF2B5EF4-FFF2-40B4-BE49-F238E27FC236}">
-                    <a16:creationId xmlns:a16="http://schemas.microsoft.com/office/drawing/2014/main" id="{32CFECD5-268A-8D1F-FD4A-FD8E284D40EF}"/>
-                  </a:ext>
-                </a:extLst>
-              </p:cNvPr>
-              <p:cNvSpPr txBox="1"/>
-              <p:nvPr/>
-            </p:nvSpPr>
-            <p:spPr>
-              <a:xfrm>
-                <a:off x="5970208" y="1819192"/>
-                <a:ext cx="1419795" cy="631648"/>
-              </a:xfrm>
-              <a:prstGeom prst="rect">
-                <a:avLst/>
-              </a:prstGeom>
-              <a:noFill/>
-            </p:spPr>
-            <p:txBody>
-              <a:bodyPr wrap="square">
-                <a:spAutoFit/>
-              </a:bodyPr>
-              <a:lstStyle/>
-              <a:p>
-                <a:pPr/>
-                <a14:m>
-                  <m:oMathPara xmlns:m="http://schemas.openxmlformats.org/officeDocument/2006/math">
-                    <m:oMathParaPr>
-                      <m:jc m:val="centerGroup"/>
-                    </m:oMathParaPr>
-                    <m:oMath xmlns:m="http://schemas.openxmlformats.org/officeDocument/2006/math">
-                      <m:f>
-                        <m:fPr>
-                          <m:ctrlPr>
-                            <a:rPr lang="x-IV_mathan" i="1" smtClean="0">
-                              <a:solidFill>
-                                <a:srgbClr val="44546A"/>
-                              </a:solidFill>
-                              <a:latin typeface="Cambria Math" panose="02040503050406030204" pitchFamily="18" charset="0"/>
-                              <a:ea typeface="Cambria Math" panose="02040503050406030204" pitchFamily="18" charset="0"/>
-                            </a:rPr>
-                          </m:ctrlPr>
-                        </m:fPr>
-                        <m:num>
-                          <m:r>
-                            <a:rPr lang="x-IV_mathan">
-                              <a:solidFill>
-                                <a:srgbClr val="44546A"/>
-                              </a:solidFill>
-                              <a:latin typeface="Cambria Math" panose="02040503050406030204" pitchFamily="18" charset="0"/>
-                              <a:ea typeface="Cambria Math" panose="02040503050406030204" pitchFamily="18" charset="0"/>
-                            </a:rPr>
-                            <m:t>𝜕</m:t>
-                          </m:r>
-                          <m:sSub>
-                            <m:sSubPr>
-                              <m:ctrlPr>
-                                <a:rPr lang="x-IV_mathan" i="1">
-                                  <a:solidFill>
-                                    <a:srgbClr val="44546A"/>
-                                  </a:solidFill>
-                                  <a:latin typeface="Cambria Math" panose="02040503050406030204" pitchFamily="18" charset="0"/>
-                                  <a:ea typeface="Cambria Math" panose="02040503050406030204" pitchFamily="18" charset="0"/>
-                                </a:rPr>
-                              </m:ctrlPr>
-                            </m:sSubPr>
-                            <m:e>
-                              <m:r>
-                                <a:rPr lang="x-IV_mathan">
-                                  <a:solidFill>
-                                    <a:srgbClr val="44546A"/>
-                                  </a:solidFill>
-                                  <a:latin typeface="Cambria Math" panose="02040503050406030204" pitchFamily="18" charset="0"/>
-                                  <a:ea typeface="Cambria Math" panose="02040503050406030204" pitchFamily="18" charset="0"/>
-                                </a:rPr>
-                                <m:t>𝐶</m:t>
-                              </m:r>
-                            </m:e>
-                            <m:sub>
-                              <m:r>
-                                <a:rPr lang="x-IV_mathan">
-                                  <a:solidFill>
-                                    <a:srgbClr val="44546A"/>
-                                  </a:solidFill>
-                                  <a:latin typeface="Cambria Math" panose="02040503050406030204" pitchFamily="18" charset="0"/>
-                                  <a:ea typeface="Cambria Math" panose="02040503050406030204" pitchFamily="18" charset="0"/>
-                                </a:rPr>
-                                <m:t>/</m:t>
-                              </m:r>
-                              <m:r>
-                                <a:rPr lang="x-IV_mathan">
-                                  <a:solidFill>
-                                    <a:srgbClr val="44546A"/>
-                                  </a:solidFill>
-                                  <a:latin typeface="Cambria Math" panose="02040503050406030204" pitchFamily="18" charset="0"/>
-                                  <a:ea typeface="Cambria Math" panose="02040503050406030204" pitchFamily="18" charset="0"/>
-                                </a:rPr>
-                                <m:t>𝑖𝑚𝑎𝑔𝑒</m:t>
-                              </m:r>
-                            </m:sub>
-                          </m:sSub>
-                        </m:num>
-                        <m:den>
-                          <m:r>
-                            <a:rPr lang="x-IV_mathan">
-                              <a:solidFill>
-                                <a:srgbClr val="44546A"/>
-                              </a:solidFill>
-                              <a:latin typeface="Cambria Math" panose="02040503050406030204" pitchFamily="18" charset="0"/>
-                              <a:ea typeface="Cambria Math" panose="02040503050406030204" pitchFamily="18" charset="0"/>
-                            </a:rPr>
-                            <m:t>𝜕</m:t>
-                          </m:r>
-                          <m:sSup>
-                            <m:sSupPr>
-                              <m:ctrlPr>
-                                <a:rPr lang="x-IV_mathan" i="1">
-                                  <a:solidFill>
-                                    <a:srgbClr val="44546A"/>
-                                  </a:solidFill>
-                                  <a:latin typeface="Cambria Math" panose="02040503050406030204" pitchFamily="18" charset="0"/>
-                                  <a:ea typeface="Cambria Math" panose="02040503050406030204" pitchFamily="18" charset="0"/>
-                                </a:rPr>
-                              </m:ctrlPr>
-                            </m:sSupPr>
-                            <m:e>
-                              <m:r>
-                                <a:rPr lang="fr-FR" i="1">
-                                  <a:solidFill>
-                                    <a:srgbClr val="44546A"/>
-                                  </a:solidFill>
-                                  <a:latin typeface="Cambria Math" panose="02040503050406030204" pitchFamily="18" charset="0"/>
-                                  <a:ea typeface="Cambria Math" panose="02040503050406030204" pitchFamily="18" charset="0"/>
-                                </a:rPr>
-                                <m:t>𝑊</m:t>
-                              </m:r>
-                            </m:e>
-                            <m:sup>
-                              <m:r>
-                                <a:rPr lang="fr-FR" i="1">
-                                  <a:solidFill>
-                                    <a:srgbClr val="44546A"/>
-                                  </a:solidFill>
-                                  <a:latin typeface="Cambria Math" panose="02040503050406030204" pitchFamily="18" charset="0"/>
-                                  <a:ea typeface="Cambria Math" panose="02040503050406030204" pitchFamily="18" charset="0"/>
-                                </a:rPr>
-                                <m:t>𝑖</m:t>
-                              </m:r>
-                            </m:sup>
-                          </m:sSup>
-                        </m:den>
-                      </m:f>
-                      <m:r>
-                        <a:rPr lang="fr-FR" b="0" i="0" smtClean="0">
-                          <a:solidFill>
-                            <a:srgbClr val="44546A"/>
-                          </a:solidFill>
-                          <a:latin typeface="Cambria Math" panose="02040503050406030204" pitchFamily="18" charset="0"/>
-                          <a:ea typeface="Cambria Math" panose="02040503050406030204" pitchFamily="18" charset="0"/>
-                        </a:rPr>
-                        <m:t>=</m:t>
-                      </m:r>
-                    </m:oMath>
-                  </m:oMathPara>
-                </a14:m>
-                <a:endParaRPr lang="fr-FR" dirty="0"/>
-              </a:p>
-            </p:txBody>
-          </p:sp>
-        </mc:Choice>
-        <mc:Fallback xmlns="">
-          <p:sp>
-            <p:nvSpPr>
-              <p:cNvPr id="38" name="ZoneTexte 37">
-                <a:extLst>
-                  <a:ext uri="{FF2B5EF4-FFF2-40B4-BE49-F238E27FC236}">
-                    <a16:creationId xmlns:a16="http://schemas.microsoft.com/office/drawing/2014/main" id="{32CFECD5-268A-8D1F-FD4A-FD8E284D40EF}"/>
-                  </a:ext>
-                </a:extLst>
-              </p:cNvPr>
-              <p:cNvSpPr txBox="1">
-                <a:spLocks noRot="1" noChangeAspect="1" noMove="1" noResize="1" noEditPoints="1" noAdjustHandles="1" noChangeArrowheads="1" noChangeShapeType="1" noTextEdit="1"/>
-              </p:cNvSpPr>
-              <p:nvPr/>
-            </p:nvSpPr>
-            <p:spPr>
-              <a:xfrm>
-                <a:off x="5970208" y="1819192"/>
-                <a:ext cx="1419795" cy="631648"/>
-              </a:xfrm>
-              <a:prstGeom prst="rect">
-                <a:avLst/>
-              </a:prstGeom>
-              <a:blipFill>
-                <a:blip r:embed="rId5"/>
-                <a:stretch>
-                  <a:fillRect/>
-                </a:stretch>
-              </a:blipFill>
-            </p:spPr>
-            <p:txBody>
-              <a:bodyPr/>
-              <a:lstStyle/>
-              <a:p>
-                <a:r>
-                  <a:rPr lang="fr-FR">
-                    <a:noFill/>
-                  </a:rPr>
-                  <a:t> </a:t>
-                </a:r>
-              </a:p>
-            </p:txBody>
-          </p:sp>
-        </mc:Fallback>
-      </mc:AlternateContent>
-      <mc:AlternateContent xmlns:mc="http://schemas.openxmlformats.org/markup-compatibility/2006" xmlns:a14="http://schemas.microsoft.com/office/drawing/2010/main">
-        <mc:Choice Requires="a14">
+      <mc:AlternateContent xmlns:mc="http://schemas.openxmlformats.org/markup-compatibility/2006">
+        <mc:Choice xmlns:a14="http://schemas.microsoft.com/office/drawing/2010/main" Requires="a14">
           <p:sp>
             <p:nvSpPr>
               <p:cNvPr id="40" name="ZoneTexte 39">
@@ -27671,8 +27618,8 @@
             </p:nvSpPr>
             <p:spPr>
               <a:xfrm>
-                <a:off x="5557194" y="3515271"/>
-                <a:ext cx="1576777" cy="518860"/>
+                <a:off x="5591700" y="913013"/>
+                <a:ext cx="6600300" cy="1534266"/>
               </a:xfrm>
               <a:prstGeom prst="rect">
                 <a:avLst/>
@@ -27696,10 +27643,10 @@
                 </a:r>
                 <a14:m>
                   <m:oMath xmlns:m="http://schemas.openxmlformats.org/officeDocument/2006/math">
-                    <m:f>
-                      <m:fPr>
+                    <m:borderBox>
+                      <m:borderBoxPr>
                         <m:ctrlPr>
-                          <a:rPr lang="x-IV_mathan" i="1" smtClean="0">
+                          <a:rPr lang="x-IV_mathan" b="1" i="1" smtClean="0">
                             <a:solidFill>
                               <a:srgbClr val="44546A"/>
                             </a:solidFill>
@@ -27707,20 +27654,10 @@
                             <a:ea typeface="Cambria Math" panose="02040503050406030204" pitchFamily="18" charset="0"/>
                           </a:rPr>
                         </m:ctrlPr>
-                      </m:fPr>
-                      <m:num>
-                        <m:r>
-                          <a:rPr lang="x-IV_mathan">
-                            <a:solidFill>
-                              <a:srgbClr val="44546A"/>
-                            </a:solidFill>
-                            <a:latin typeface="Cambria Math" panose="02040503050406030204" pitchFamily="18" charset="0"/>
-                            <a:ea typeface="Cambria Math" panose="02040503050406030204" pitchFamily="18" charset="0"/>
-                          </a:rPr>
-                          <m:t>𝜕</m:t>
-                        </m:r>
-                        <m:sSub>
-                          <m:sSubPr>
+                      </m:borderBoxPr>
+                      <m:e>
+                        <m:f>
+                          <m:fPr>
                             <m:ctrlPr>
                               <a:rPr lang="x-IV_mathan" i="1">
                                 <a:solidFill>
@@ -27730,8 +27667,8 @@
                                 <a:ea typeface="Cambria Math" panose="02040503050406030204" pitchFamily="18" charset="0"/>
                               </a:rPr>
                             </m:ctrlPr>
-                          </m:sSubPr>
-                          <m:e>
+                          </m:fPr>
+                          <m:num>
                             <m:r>
                               <a:rPr lang="x-IV_mathan">
                                 <a:solidFill>
@@ -27740,10 +27677,57 @@
                                 <a:latin typeface="Cambria Math" panose="02040503050406030204" pitchFamily="18" charset="0"/>
                                 <a:ea typeface="Cambria Math" panose="02040503050406030204" pitchFamily="18" charset="0"/>
                               </a:rPr>
-                              <m:t>𝐶</m:t>
+                              <m:t>𝜕</m:t>
                             </m:r>
-                          </m:e>
-                          <m:sub>
+                            <m:sSub>
+                              <m:sSubPr>
+                                <m:ctrlPr>
+                                  <a:rPr lang="x-IV_mathan" i="1">
+                                    <a:solidFill>
+                                      <a:srgbClr val="44546A"/>
+                                    </a:solidFill>
+                                    <a:latin typeface="Cambria Math" panose="02040503050406030204" pitchFamily="18" charset="0"/>
+                                    <a:ea typeface="Cambria Math" panose="02040503050406030204" pitchFamily="18" charset="0"/>
+                                  </a:rPr>
+                                </m:ctrlPr>
+                              </m:sSubPr>
+                              <m:e>
+                                <m:r>
+                                  <a:rPr lang="x-IV_mathan">
+                                    <a:solidFill>
+                                      <a:srgbClr val="44546A"/>
+                                    </a:solidFill>
+                                    <a:latin typeface="Cambria Math" panose="02040503050406030204" pitchFamily="18" charset="0"/>
+                                    <a:ea typeface="Cambria Math" panose="02040503050406030204" pitchFamily="18" charset="0"/>
+                                  </a:rPr>
+                                  <m:t>𝐶</m:t>
+                                </m:r>
+                              </m:e>
+                              <m:sub>
+                                <m:r>
+                                  <a:rPr lang="x-IV_mathan">
+                                    <a:solidFill>
+                                      <a:srgbClr val="44546A"/>
+                                    </a:solidFill>
+                                    <a:latin typeface="Cambria Math" panose="02040503050406030204" pitchFamily="18" charset="0"/>
+                                    <a:ea typeface="Cambria Math" panose="02040503050406030204" pitchFamily="18" charset="0"/>
+                                  </a:rPr>
+                                  <m:t>/</m:t>
+                                </m:r>
+                                <m:r>
+                                  <a:rPr lang="fr-FR" b="0" i="1" smtClean="0">
+                                    <a:solidFill>
+                                      <a:srgbClr val="44546A"/>
+                                    </a:solidFill>
+                                    <a:latin typeface="Cambria Math" panose="02040503050406030204" pitchFamily="18" charset="0"/>
+                                    <a:ea typeface="Cambria Math" panose="02040503050406030204" pitchFamily="18" charset="0"/>
+                                  </a:rPr>
+                                  <m:t>𝑏𝑎𝑡𝑐h</m:t>
+                                </m:r>
+                              </m:sub>
+                            </m:sSub>
+                          </m:num>
+                          <m:den>
                             <m:r>
                               <a:rPr lang="x-IV_mathan">
                                 <a:solidFill>
@@ -27752,36 +27736,81 @@
                                 <a:latin typeface="Cambria Math" panose="02040503050406030204" pitchFamily="18" charset="0"/>
                                 <a:ea typeface="Cambria Math" panose="02040503050406030204" pitchFamily="18" charset="0"/>
                               </a:rPr>
-                              <m:t>/</m:t>
+                              <m:t>𝜕</m:t>
                             </m:r>
-                            <m:r>
-                              <a:rPr lang="x-IV_mathan">
-                                <a:solidFill>
-                                  <a:srgbClr val="44546A"/>
-                                </a:solidFill>
-                                <a:latin typeface="Cambria Math" panose="02040503050406030204" pitchFamily="18" charset="0"/>
-                                <a:ea typeface="Cambria Math" panose="02040503050406030204" pitchFamily="18" charset="0"/>
-                              </a:rPr>
-                              <m:t>𝑖𝑚𝑎𝑔𝑒</m:t>
-                            </m:r>
-                          </m:sub>
-                        </m:sSub>
-                      </m:num>
-                      <m:den>
+                            <m:sSup>
+                              <m:sSupPr>
+                                <m:ctrlPr>
+                                  <a:rPr lang="x-IV_mathan" b="1" i="1">
+                                    <a:solidFill>
+                                      <a:srgbClr val="44546A"/>
+                                    </a:solidFill>
+                                    <a:latin typeface="Cambria Math" panose="02040503050406030204" pitchFamily="18" charset="0"/>
+                                    <a:ea typeface="Cambria Math" panose="02040503050406030204" pitchFamily="18" charset="0"/>
+                                  </a:rPr>
+                                </m:ctrlPr>
+                              </m:sSupPr>
+                              <m:e>
+                                <m:r>
+                                  <a:rPr lang="fr-FR" b="1">
+                                    <a:solidFill>
+                                      <a:srgbClr val="44546A"/>
+                                    </a:solidFill>
+                                    <a:latin typeface="Cambria Math" panose="02040503050406030204" pitchFamily="18" charset="0"/>
+                                    <a:ea typeface="Cambria Math" panose="02040503050406030204" pitchFamily="18" charset="0"/>
+                                  </a:rPr>
+                                  <m:t>𝐖</m:t>
+                                </m:r>
+                              </m:e>
+                              <m:sup>
+                                <m:r>
+                                  <a:rPr lang="fr-FR" b="1">
+                                    <a:solidFill>
+                                      <a:srgbClr val="44546A"/>
+                                    </a:solidFill>
+                                    <a:latin typeface="Cambria Math" panose="02040503050406030204" pitchFamily="18" charset="0"/>
+                                    <a:ea typeface="Cambria Math" panose="02040503050406030204" pitchFamily="18" charset="0"/>
+                                  </a:rPr>
+                                  <m:t>𝐢</m:t>
+                                </m:r>
+                                <m:r>
+                                  <a:rPr lang="fr-FR" b="1" i="1" smtClean="0">
+                                    <a:solidFill>
+                                      <a:srgbClr val="44546A"/>
+                                    </a:solidFill>
+                                    <a:latin typeface="Cambria Math" panose="02040503050406030204" pitchFamily="18" charset="0"/>
+                                    <a:ea typeface="Cambria Math" panose="02040503050406030204" pitchFamily="18" charset="0"/>
+                                  </a:rPr>
+                                  <m:t>,</m:t>
+                                </m:r>
+                                <m:r>
+                                  <a:rPr lang="fr-FR" b="1" i="1" smtClean="0">
+                                    <a:solidFill>
+                                      <a:srgbClr val="44546A"/>
+                                    </a:solidFill>
+                                    <a:latin typeface="Cambria Math" panose="02040503050406030204" pitchFamily="18" charset="0"/>
+                                    <a:ea typeface="Cambria Math" panose="02040503050406030204" pitchFamily="18" charset="0"/>
+                                  </a:rPr>
+                                  <m:t>𝒃</m:t>
+                                </m:r>
+                              </m:sup>
+                            </m:sSup>
+                          </m:den>
+                        </m:f>
                         <m:r>
-                          <a:rPr lang="x-IV_mathan">
+                          <a:rPr lang="fr-FR">
                             <a:solidFill>
                               <a:srgbClr val="44546A"/>
                             </a:solidFill>
                             <a:latin typeface="Cambria Math" panose="02040503050406030204" pitchFamily="18" charset="0"/>
                             <a:ea typeface="Cambria Math" panose="02040503050406030204" pitchFamily="18" charset="0"/>
                           </a:rPr>
-                          <m:t>𝜕</m:t>
+                          <m:t>=−</m:t>
                         </m:r>
                         <m:sSup>
                           <m:sSupPr>
                             <m:ctrlPr>
-                              <a:rPr lang="x-IV_mathan" b="1" i="1">
+                              <a:rPr lang="x-IV_mathan" i="1">
                                 <a:solidFill>
                                   <a:srgbClr val="44546A"/>
                                 </a:solidFill>
@@ -27791,50 +27820,431 @@
                             </m:ctrlPr>
                           </m:sSupPr>
                           <m:e>
-                            <m:r>
-                              <a:rPr lang="fr-FR" b="1" i="0">
+                            <m:d>
+                              <m:dPr>
+                                <m:ctrlPr>
+                                  <a:rPr lang="x-IV_mathan" i="1">
+                                    <a:solidFill>
+                                      <a:srgbClr val="44546A"/>
+                                    </a:solidFill>
+                                    <a:latin typeface="Cambria Math" panose="02040503050406030204" pitchFamily="18" charset="0"/>
+                                    <a:ea typeface="Cambria Math" panose="02040503050406030204" pitchFamily="18" charset="0"/>
+                                  </a:rPr>
+                                </m:ctrlPr>
+                              </m:dPr>
+                              <m:e>
+                                <m:f>
+                                  <m:fPr>
+                                    <m:ctrlPr>
+                                      <a:rPr lang="x-IV_mathan" i="1">
+                                        <a:solidFill>
+                                          <a:srgbClr val="44546A"/>
+                                        </a:solidFill>
+                                        <a:latin typeface="Cambria Math" panose="02040503050406030204" pitchFamily="18" charset="0"/>
+                                        <a:ea typeface="Cambria Math" panose="02040503050406030204" pitchFamily="18" charset="0"/>
+                                      </a:rPr>
+                                    </m:ctrlPr>
+                                  </m:fPr>
+                                  <m:num>
+                                    <m:r>
+                                      <a:rPr lang="x-IV_mathan">
+                                        <a:solidFill>
+                                          <a:srgbClr val="44546A"/>
+                                        </a:solidFill>
+                                        <a:latin typeface="Cambria Math" panose="02040503050406030204" pitchFamily="18" charset="0"/>
+                                        <a:ea typeface="Cambria Math" panose="02040503050406030204" pitchFamily="18" charset="0"/>
+                                      </a:rPr>
+                                      <m:t>𝜕</m:t>
+                                    </m:r>
+                                    <m:sSub>
+                                      <m:sSubPr>
+                                        <m:ctrlPr>
+                                          <a:rPr lang="x-IV_mathan" i="1">
+                                            <a:solidFill>
+                                              <a:srgbClr val="44546A"/>
+                                            </a:solidFill>
+                                            <a:latin typeface="Cambria Math" panose="02040503050406030204" pitchFamily="18" charset="0"/>
+                                            <a:ea typeface="Cambria Math" panose="02040503050406030204" pitchFamily="18" charset="0"/>
+                                          </a:rPr>
+                                        </m:ctrlPr>
+                                      </m:sSubPr>
+                                      <m:e>
+                                        <m:r>
+                                          <a:rPr lang="x-IV_mathan">
+                                            <a:solidFill>
+                                              <a:srgbClr val="44546A"/>
+                                            </a:solidFill>
+                                            <a:latin typeface="Cambria Math" panose="02040503050406030204" pitchFamily="18" charset="0"/>
+                                            <a:ea typeface="Cambria Math" panose="02040503050406030204" pitchFamily="18" charset="0"/>
+                                          </a:rPr>
+                                          <m:t>𝐶</m:t>
+                                        </m:r>
+                                      </m:e>
+                                      <m:sub>
+                                        <m:r>
+                                          <a:rPr lang="fr-FR" i="1">
+                                            <a:solidFill>
+                                              <a:srgbClr val="44546A"/>
+                                            </a:solidFill>
+                                            <a:latin typeface="Cambria Math" panose="02040503050406030204" pitchFamily="18" charset="0"/>
+                                            <a:ea typeface="Cambria Math" panose="02040503050406030204" pitchFamily="18" charset="0"/>
+                                          </a:rPr>
+                                          <m:t>/</m:t>
+                                        </m:r>
+                                        <m:r>
+                                          <a:rPr lang="fr-FR" b="0" i="1" smtClean="0">
+                                            <a:solidFill>
+                                              <a:srgbClr val="44546A"/>
+                                            </a:solidFill>
+                                            <a:latin typeface="Cambria Math" panose="02040503050406030204" pitchFamily="18" charset="0"/>
+                                            <a:ea typeface="Cambria Math" panose="02040503050406030204" pitchFamily="18" charset="0"/>
+                                          </a:rPr>
+                                          <m:t>𝑏𝑎𝑡𝑐h</m:t>
+                                        </m:r>
+                                      </m:sub>
+                                    </m:sSub>
+                                  </m:num>
+                                  <m:den>
+                                    <m:r>
+                                      <a:rPr lang="x-IV_mathan">
+                                        <a:solidFill>
+                                          <a:srgbClr val="44546A"/>
+                                        </a:solidFill>
+                                        <a:latin typeface="Cambria Math" panose="02040503050406030204" pitchFamily="18" charset="0"/>
+                                        <a:ea typeface="Cambria Math" panose="02040503050406030204" pitchFamily="18" charset="0"/>
+                                      </a:rPr>
+                                      <m:t>𝜕</m:t>
+                                    </m:r>
+                                    <m:sSup>
+                                      <m:sSupPr>
+                                        <m:ctrlPr>
+                                          <a:rPr lang="x-IV_mathan" i="1">
+                                            <a:solidFill>
+                                              <a:srgbClr val="44546A"/>
+                                            </a:solidFill>
+                                            <a:latin typeface="Cambria Math" panose="02040503050406030204" pitchFamily="18" charset="0"/>
+                                            <a:ea typeface="Cambria Math" panose="02040503050406030204" pitchFamily="18" charset="0"/>
+                                          </a:rPr>
+                                        </m:ctrlPr>
+                                      </m:sSupPr>
+                                      <m:e>
+                                        <m:r>
+                                          <a:rPr lang="fr-FR" b="1">
+                                            <a:solidFill>
+                                              <a:srgbClr val="44546A"/>
+                                            </a:solidFill>
+                                            <a:latin typeface="Cambria Math" panose="02040503050406030204" pitchFamily="18" charset="0"/>
+                                            <a:ea typeface="Cambria Math" panose="02040503050406030204" pitchFamily="18" charset="0"/>
+                                          </a:rPr>
+                                          <m:t>𝐁</m:t>
+                                        </m:r>
+                                      </m:e>
+                                      <m:sup>
+                                        <m:r>
+                                          <a:rPr lang="fr-FR" i="1">
+                                            <a:solidFill>
+                                              <a:srgbClr val="44546A"/>
+                                            </a:solidFill>
+                                            <a:latin typeface="Cambria Math" panose="02040503050406030204" pitchFamily="18" charset="0"/>
+                                            <a:ea typeface="Cambria Math" panose="02040503050406030204" pitchFamily="18" charset="0"/>
+                                          </a:rPr>
+                                          <m:t>𝑖</m:t>
+                                        </m:r>
+                                      </m:sup>
+                                    </m:sSup>
+                                  </m:den>
+                                </m:f>
+                              </m:e>
+                            </m:d>
+                          </m:e>
+                          <m:sup>
+                            <m:sSub>
+                              <m:sSubPr>
+                                <m:ctrlPr>
+                                  <a:rPr lang="fr-FR" i="1" smtClean="0">
+                                    <a:solidFill>
+                                      <a:srgbClr val="44546A"/>
+                                    </a:solidFill>
+                                    <a:latin typeface="Cambria Math" panose="02040503050406030204" pitchFamily="18" charset="0"/>
+                                    <a:ea typeface="Cambria Math" panose="02040503050406030204" pitchFamily="18" charset="0"/>
+                                  </a:rPr>
+                                </m:ctrlPr>
+                              </m:sSubPr>
+                              <m:e>
+                                <m:r>
+                                  <a:rPr lang="fr-FR" b="0" i="1" smtClean="0">
+                                    <a:solidFill>
+                                      <a:srgbClr val="44546A"/>
+                                    </a:solidFill>
+                                    <a:latin typeface="Cambria Math" panose="02040503050406030204" pitchFamily="18" charset="0"/>
+                                    <a:ea typeface="Cambria Math" panose="02040503050406030204" pitchFamily="18" charset="0"/>
+                                  </a:rPr>
+                                  <m:t>𝑅</m:t>
+                                </m:r>
+                              </m:e>
+                              <m:sub>
+                                <m:r>
+                                  <a:rPr lang="fr-FR" b="0" i="1" smtClean="0">
+                                    <a:solidFill>
+                                      <a:srgbClr val="44546A"/>
+                                    </a:solidFill>
+                                    <a:latin typeface="Cambria Math" panose="02040503050406030204" pitchFamily="18" charset="0"/>
+                                    <a:ea typeface="Cambria Math" panose="02040503050406030204" pitchFamily="18" charset="0"/>
+                                  </a:rPr>
+                                  <m:t>1</m:t>
+                                </m:r>
+                              </m:sub>
+                            </m:sSub>
+                          </m:sup>
+                        </m:sSup>
+                        <m:r>
+                          <a:rPr lang="fr-FR" i="1" smtClean="0">
+                            <a:solidFill>
+                              <a:srgbClr val="44546A"/>
+                            </a:solidFill>
+                            <a:latin typeface="Cambria Math" panose="02040503050406030204" pitchFamily="18" charset="0"/>
+                            <a:ea typeface="Cambria Math" panose="02040503050406030204" pitchFamily="18" charset="0"/>
+                          </a:rPr>
+                          <m:t>∗</m:t>
+                        </m:r>
+                        <m:sSup>
+                          <m:sSupPr>
+                            <m:ctrlPr>
+                              <a:rPr lang="fr-FR" i="1" smtClean="0">
                                 <a:solidFill>
                                   <a:srgbClr val="44546A"/>
                                 </a:solidFill>
                                 <a:latin typeface="Cambria Math" panose="02040503050406030204" pitchFamily="18" charset="0"/>
                                 <a:ea typeface="Cambria Math" panose="02040503050406030204" pitchFamily="18" charset="0"/>
                               </a:rPr>
-                              <m:t>𝐖</m:t>
-                            </m:r>
+                            </m:ctrlPr>
+                          </m:sSupPr>
+                          <m:e>
+                            <m:sSup>
+                              <m:sSupPr>
+                                <m:ctrlPr>
+                                  <a:rPr lang="fr-FR" b="1" i="1" smtClean="0">
+                                    <a:solidFill>
+                                      <a:srgbClr val="44546A"/>
+                                    </a:solidFill>
+                                    <a:latin typeface="Cambria Math" panose="02040503050406030204" pitchFamily="18" charset="0"/>
+                                    <a:ea typeface="Cambria Math" panose="02040503050406030204" pitchFamily="18" charset="0"/>
+                                  </a:rPr>
+                                </m:ctrlPr>
+                              </m:sSupPr>
+                              <m:e>
+                                <m:r>
+                                  <a:rPr lang="fr-FR" b="1" i="0" smtClean="0">
+                                    <a:solidFill>
+                                      <a:srgbClr val="44546A"/>
+                                    </a:solidFill>
+                                    <a:latin typeface="Cambria Math" panose="02040503050406030204" pitchFamily="18" charset="0"/>
+                                    <a:ea typeface="Cambria Math" panose="02040503050406030204" pitchFamily="18" charset="0"/>
+                                  </a:rPr>
+                                  <m:t>𝐀</m:t>
+                                </m:r>
+                              </m:e>
+                              <m:sup>
+                                <m:r>
+                                  <a:rPr lang="fr-FR" b="1" i="0" smtClean="0">
+                                    <a:solidFill>
+                                      <a:srgbClr val="44546A"/>
+                                    </a:solidFill>
+                                    <a:latin typeface="Cambria Math" panose="02040503050406030204" pitchFamily="18" charset="0"/>
+                                    <a:ea typeface="Cambria Math" panose="02040503050406030204" pitchFamily="18" charset="0"/>
+                                  </a:rPr>
+                                  <m:t>𝐢</m:t>
+                                </m:r>
+                                <m:r>
+                                  <a:rPr lang="fr-FR" b="1" i="0" smtClean="0">
+                                    <a:solidFill>
+                                      <a:srgbClr val="44546A"/>
+                                    </a:solidFill>
+                                    <a:latin typeface="Cambria Math" panose="02040503050406030204" pitchFamily="18" charset="0"/>
+                                    <a:ea typeface="Cambria Math" panose="02040503050406030204" pitchFamily="18" charset="0"/>
+                                  </a:rPr>
+                                  <m:t>−</m:t>
+                                </m:r>
+                                <m:r>
+                                  <a:rPr lang="fr-FR" b="1" i="0" smtClean="0">
+                                    <a:solidFill>
+                                      <a:srgbClr val="44546A"/>
+                                    </a:solidFill>
+                                    <a:latin typeface="Cambria Math" panose="02040503050406030204" pitchFamily="18" charset="0"/>
+                                    <a:ea typeface="Cambria Math" panose="02040503050406030204" pitchFamily="18" charset="0"/>
+                                  </a:rPr>
+                                  <m:t>𝟏</m:t>
+                                </m:r>
+                              </m:sup>
+                            </m:sSup>
                           </m:e>
                           <m:sup>
-                            <m:r>
-                              <a:rPr lang="fr-FR" b="1" i="0">
-                                <a:solidFill>
-                                  <a:srgbClr val="44546A"/>
-                                </a:solidFill>
-                                <a:latin typeface="Cambria Math" panose="02040503050406030204" pitchFamily="18" charset="0"/>
-                                <a:ea typeface="Cambria Math" panose="02040503050406030204" pitchFamily="18" charset="0"/>
-                              </a:rPr>
-                              <m:t>𝐢</m:t>
-                            </m:r>
+                            <m:sSub>
+                              <m:sSubPr>
+                                <m:ctrlPr>
+                                  <a:rPr lang="fr-FR" i="1" smtClean="0">
+                                    <a:solidFill>
+                                      <a:srgbClr val="44546A"/>
+                                    </a:solidFill>
+                                    <a:latin typeface="Cambria Math" panose="02040503050406030204" pitchFamily="18" charset="0"/>
+                                    <a:ea typeface="Cambria Math" panose="02040503050406030204" pitchFamily="18" charset="0"/>
+                                  </a:rPr>
+                                </m:ctrlPr>
+                              </m:sSubPr>
+                              <m:e>
+                                <m:r>
+                                  <a:rPr lang="fr-FR" b="0" i="1" smtClean="0">
+                                    <a:solidFill>
+                                      <a:srgbClr val="44546A"/>
+                                    </a:solidFill>
+                                    <a:latin typeface="Cambria Math" panose="02040503050406030204" pitchFamily="18" charset="0"/>
+                                    <a:ea typeface="Cambria Math" panose="02040503050406030204" pitchFamily="18" charset="0"/>
+                                  </a:rPr>
+                                  <m:t>𝑅</m:t>
+                                </m:r>
+                              </m:e>
+                              <m:sub>
+                                <m:r>
+                                  <a:rPr lang="fr-FR" b="0" i="1" smtClean="0">
+                                    <a:solidFill>
+                                      <a:srgbClr val="44546A"/>
+                                    </a:solidFill>
+                                    <a:latin typeface="Cambria Math" panose="02040503050406030204" pitchFamily="18" charset="0"/>
+                                    <a:ea typeface="Cambria Math" panose="02040503050406030204" pitchFamily="18" charset="0"/>
+                                  </a:rPr>
+                                  <m:t>2</m:t>
+                                </m:r>
+                              </m:sub>
+                            </m:sSub>
                           </m:sup>
                         </m:sSup>
-                      </m:den>
-                    </m:f>
-                    <m:r>
-                      <a:rPr lang="fr-FR" b="0" i="0" smtClean="0">
-                        <a:solidFill>
-                          <a:srgbClr val="44546A"/>
-                        </a:solidFill>
-                        <a:latin typeface="Cambria Math" panose="02040503050406030204" pitchFamily="18" charset="0"/>
-                        <a:ea typeface="Cambria Math" panose="02040503050406030204" pitchFamily="18" charset="0"/>
-                      </a:rPr>
-                      <m:t>=</m:t>
-                    </m:r>
+                      </m:e>
+                    </m:borderBox>
                   </m:oMath>
                 </a14:m>
-                <a:endParaRPr lang="fr-FR" dirty="0"/>
+                <a:r>
+                  <a:rPr lang="fr-FR" dirty="0">
+                    <a:solidFill>
+                      <a:srgbClr val="44546A"/>
+                    </a:solidFill>
+                    <a:latin typeface="Cambria Math" panose="02040503050406030204" pitchFamily="18" charset="0"/>
+                  </a:rPr>
+                  <a:t>, </a:t>
+                </a:r>
+                <a:r>
+                  <a:rPr lang="fr-FR" dirty="0" err="1">
+                    <a:solidFill>
+                      <a:srgbClr val="44546A"/>
+                    </a:solidFill>
+                    <a:latin typeface="Cambria Math" panose="02040503050406030204" pitchFamily="18" charset="0"/>
+                  </a:rPr>
+                  <a:t>where</a:t>
+                </a:r>
+                <a:r>
+                  <a:rPr lang="fr-FR" dirty="0">
+                    <a:solidFill>
+                      <a:srgbClr val="44546A"/>
+                    </a:solidFill>
+                    <a:latin typeface="Cambria Math" panose="02040503050406030204" pitchFamily="18" charset="0"/>
+                  </a:rPr>
+                  <a:t> R1 and R2 </a:t>
+                </a:r>
+                <a:r>
+                  <a:rPr lang="fr-FR" dirty="0" err="1">
+                    <a:solidFill>
+                      <a:srgbClr val="44546A"/>
+                    </a:solidFill>
+                    <a:latin typeface="Cambria Math" panose="02040503050406030204" pitchFamily="18" charset="0"/>
+                  </a:rPr>
+                  <a:t>represent</a:t>
+                </a:r>
+                <a:r>
+                  <a:rPr lang="fr-FR" dirty="0">
+                    <a:solidFill>
+                      <a:srgbClr val="44546A"/>
+                    </a:solidFill>
+                    <a:latin typeface="Cambria Math" panose="02040503050406030204" pitchFamily="18" charset="0"/>
+                  </a:rPr>
+                  <a:t> certain rotations in </a:t>
+                </a:r>
+                <a:r>
+                  <a:rPr lang="fr-FR" dirty="0" err="1">
+                    <a:solidFill>
+                      <a:srgbClr val="44546A"/>
+                    </a:solidFill>
+                    <a:latin typeface="Cambria Math" panose="02040503050406030204" pitchFamily="18" charset="0"/>
+                  </a:rPr>
+                  <a:t>space</a:t>
+                </a:r>
+                <a:r>
+                  <a:rPr lang="fr-FR" dirty="0">
+                    <a:solidFill>
+                      <a:srgbClr val="44546A"/>
+                    </a:solidFill>
+                    <a:latin typeface="Cambria Math" panose="02040503050406030204" pitchFamily="18" charset="0"/>
+                  </a:rPr>
+                  <a:t> and * the </a:t>
+                </a:r>
+                <a:r>
+                  <a:rPr lang="fr-FR" dirty="0" err="1">
+                    <a:solidFill>
+                      <a:srgbClr val="44546A"/>
+                    </a:solidFill>
+                    <a:latin typeface="Cambria Math" panose="02040503050406030204" pitchFamily="18" charset="0"/>
+                  </a:rPr>
+                  <a:t>usual</a:t>
+                </a:r>
+                <a:r>
+                  <a:rPr lang="fr-FR" dirty="0">
+                    <a:solidFill>
+                      <a:srgbClr val="44546A"/>
+                    </a:solidFill>
+                    <a:latin typeface="Cambria Math" panose="02040503050406030204" pitchFamily="18" charset="0"/>
+                  </a:rPr>
+                  <a:t> dot </a:t>
+                </a:r>
+                <a:r>
+                  <a:rPr lang="fr-FR" dirty="0" err="1">
+                    <a:solidFill>
+                      <a:srgbClr val="44546A"/>
+                    </a:solidFill>
+                    <a:latin typeface="Cambria Math" panose="02040503050406030204" pitchFamily="18" charset="0"/>
+                  </a:rPr>
+                  <a:t>product</a:t>
+                </a:r>
+                <a:r>
+                  <a:rPr lang="fr-FR" dirty="0">
+                    <a:solidFill>
+                      <a:srgbClr val="44546A"/>
+                    </a:solidFill>
+                    <a:latin typeface="Cambria Math" panose="02040503050406030204" pitchFamily="18" charset="0"/>
+                  </a:rPr>
+                  <a:t> in N-d (</a:t>
+                </a:r>
+                <a:r>
+                  <a:rPr lang="fr-FR" dirty="0" err="1">
+                    <a:solidFill>
+                      <a:srgbClr val="44546A"/>
+                    </a:solidFill>
+                    <a:latin typeface="Cambria Math" panose="02040503050406030204" pitchFamily="18" charset="0"/>
+                  </a:rPr>
+                  <a:t>sum</a:t>
+                </a:r>
+                <a:r>
+                  <a:rPr lang="fr-FR" dirty="0">
+                    <a:solidFill>
+                      <a:srgbClr val="44546A"/>
+                    </a:solidFill>
+                    <a:latin typeface="Cambria Math" panose="02040503050406030204" pitchFamily="18" charset="0"/>
+                  </a:rPr>
+                  <a:t> over the second-to-last dimension of the first entry and the last dimension of the second entry).</a:t>
+                </a:r>
+                <a:endParaRPr lang="fr-FR" b="1" dirty="0"/>
               </a:p>
             </p:txBody>
           </p:sp>
         </mc:Choice>
-        <mc:Fallback xmlns="">
+        <mc:Fallback>
           <p:sp>
             <p:nvSpPr>
               <p:cNvPr id="40" name="ZoneTexte 39">
@@ -27851,16 +28261,16 @@
             </p:nvSpPr>
             <p:spPr>
               <a:xfrm>
-                <a:off x="5557194" y="3515271"/>
-                <a:ext cx="1576777" cy="518860"/>
+                <a:off x="5591700" y="913013"/>
+                <a:ext cx="6600300" cy="1534266"/>
               </a:xfrm>
               <a:prstGeom prst="rect">
                 <a:avLst/>
               </a:prstGeom>
               <a:blipFill>
-                <a:blip r:embed="rId6"/>
+                <a:blip r:embed="rId4"/>
                 <a:stretch>
-                  <a:fillRect l="-3488" b="-8235"/>
+                  <a:fillRect l="-739" r="-369" b="-4781"/>
                 </a:stretch>
               </a:blipFill>
             </p:spPr>

</xml_diff>